<commit_message>
Update pitch 2 slides and script
Co-Authored-By: Claude Opus 5.5 <noreply@anthropic.com>
</commit_message>
<xml_diff>
--- a/presentations/Better Models, Better Humans (pitch2).pptx
+++ b/presentations/Better Models, Better Humans (pitch2).pptx
@@ -919,11 +919,11 @@
               <a:rPr lang="en-US" dirty="0"/>
               <a:t>HENRI · 1:45 – 3:00
 So what do we already know? Four findings.
-First, a 2024 meta-analysis by Vaccaro and colleagues, over 106 experiments: on average, a human working with an AI does worse than the best of the two alone, especially on decisions.
-Second, Bansal and colleagues showed that explanations make people accept AI advice more, also when the AI is wrong. So an explanation isn't automatically a safeguard.
-Third, Buçinca and colleagues could reduce that over-reliance by making people think for themselves first, but users liked that design the least.
-And fourth, from psychology: people treat computers as social actors, and hearing the same words spoken makes the speaker seem more competent than reading them.
-Put these together and there's a gap. This work is almost all about text. We found few studies that take the exact same explanation, deliver it as text, voice and a face, and measure whether people take over its mistakes. That's what we want to do.
+First, Bansal and colleagues showed that explanations make people accept AI advice more, also when the AI is wrong, and Steyvers and colleagues found that longer LLM explanations raise confidence without raising accuracy. So an explanation isn't automatically a safeguard.
+Second, Schroeder and Epley: the same words make a speaker seem more competent when you hear them than when you read them.
+Third, in news and politics, people believe video more than text, but it persuades them only slightly more.
+And fourth, a warning for our own hypothesis: this year at CHI, Fernández and colleagues found that AI avatars can lower trust. That's why our tests are two-sided.
+So there's a gap. We found no study that takes the same AI explanation with one planted mistake, delivers it as text, voice and a face, and measures whether people follow it. That's what we want to do.
 Tip: the sources are on the slide. Say the author name once and don't add "this paper says…" each time.</a:t>
             </a:r>
             <a:endParaRPr lang="en-US" dirty="0"/>
@@ -1014,7 +1014,7 @@
               <a:rPr lang="en-US" dirty="0"/>
               <a:t>HENRI · 3:00 – 4:00
 Our question: when people learn something new from an AI, does a more human-like format make them more likely to adopt its mistakes?
-We expect three things. One: people trust voice and video more than text. Two, our main hypothesis: with voice, and even more with a face, more people follow the mistake. And three: that effect is bigger when the mistake sits in a harder question. Checking costs more effort there, so social cues matter more.
+We expect three things. One: people trust voice and video more than text. Two, our main hypothesis: with voice, and even more with a face, more people follow the mistake. And three: that effect is bigger when the mistake sits in a harder question. Checking costs more effort there, and persuasion research says that's exactly when people fall back on surface cues like a voice or a face.
 We also look at whether people's confidence matches whether they're right, whether they say they checked the explanation, and which format they prefer.
 And our tests are two-sided: if text turns out to be the most misleading, that's a finding too, not a failed experiment.</a:t>
             </a:r>
@@ -4311,7 +4311,22 @@
                   <a:schemeClr val="tx1"/>
                 </a:solidFill>
               </a:rPr>
-              <a:t>Explanations persuade, and a voice persuades more</a:t>
+              <a:t>Explanations persuade.</a:t>
+            </a:r>
+            <a:br>
+              <a:rPr lang="en-US" sz="3200" b="1" dirty="0">
+                <a:solidFill>
+                  <a:schemeClr val="tx1"/>
+                </a:solidFill>
+              </a:rPr>
+            </a:br>
+            <a:r>
+              <a:rPr lang="en-US" sz="3200" b="1" dirty="0">
+                <a:solidFill>
+                  <a:schemeClr val="tx1"/>
+                </a:solidFill>
+              </a:rPr>
+              <a:t>Do a voice and a face add to it?</a:t>
             </a:r>
             <a:endParaRPr lang="en-US" sz="3200" dirty="0"/>
           </a:p>
@@ -4347,7 +4362,7 @@
                   <a:schemeClr val="tx1"/>
                 </a:solidFill>
               </a:rPr>
-              <a:t>On average, human + AI teams do worse than the best of the two alone, especially on decisions.</a:t>
+              <a:t>Explanations raise acceptance and confidence, also when the AI is wrong.</a:t>
             </a:r>
             <a:endParaRPr lang="en-US" sz="1600" dirty="0"/>
           </a:p>
@@ -4386,7 +4401,7 @@
                 <a:ea typeface="Consolas" pitchFamily="34" charset="-122"/>
                 <a:cs typeface="Consolas" pitchFamily="34" charset="-120"/>
               </a:rPr>
-              <a:t>Vaccaro, Almaatouq &amp; Malone, Nature Hum. Behav. 2024 · meta-analysis, 106 experiments</a:t>
+              <a:t>Bansal et al., CHI 2021 · Steyvers et al., Nature Mach. Intell. 2025</a:t>
             </a:r>
             <a:endParaRPr lang="en-US" sz="1050" dirty="0"/>
           </a:p>
@@ -4445,7 +4460,7 @@
                   <a:schemeClr val="tx1"/>
                 </a:solidFill>
               </a:rPr>
-              <a:t>Explanations make people accept AI advice more, also when the AI is wrong.</a:t>
+              <a:t>The same words sound more competent when heard than when read.</a:t>
             </a:r>
             <a:endParaRPr lang="en-US" sz="1600" dirty="0"/>
           </a:p>
@@ -4484,7 +4499,7 @@
                 <a:ea typeface="Consolas" pitchFamily="34" charset="-122"/>
                 <a:cs typeface="Consolas" pitchFamily="34" charset="-120"/>
               </a:rPr>
-              <a:t>Bansal et al., CHI 2021</a:t>
+              <a:t>Schroeder &amp; Epley, Psych. Science 2015</a:t>
             </a:r>
             <a:endParaRPr lang="en-US" sz="1050" dirty="0"/>
           </a:p>
@@ -4543,7 +4558,7 @@
                   <a:schemeClr val="tx1"/>
                 </a:solidFill>
               </a:rPr>
-              <a:t>Making people think first reduces over-reliance, but users like that design least.</a:t>
+              <a:t>Video is believed more than text, but persuades only slightly more.</a:t>
             </a:r>
             <a:endParaRPr lang="en-US" sz="1600" dirty="0"/>
           </a:p>
@@ -4582,7 +4597,7 @@
                 <a:ea typeface="Consolas" pitchFamily="34" charset="-122"/>
                 <a:cs typeface="Consolas" pitchFamily="34" charset="-120"/>
               </a:rPr>
-              <a:t>Buçinca, Malaya &amp; Gajos, CSCW 2021</a:t>
+              <a:t>Sundar et al., JCMC 2021 · Wittenberg et al., PNAS 2021</a:t>
             </a:r>
             <a:endParaRPr lang="en-US" sz="1050" dirty="0"/>
           </a:p>
@@ -4641,7 +4656,7 @@
                   <a:schemeClr val="tx1"/>
                 </a:solidFill>
               </a:rPr>
-              <a:t>People treat computers as social actors, and the same words sound more competent when spoken.</a:t>
+              <a:t>AI avatars can lower trust, while lie-detection accuracy stays the same.</a:t>
             </a:r>
             <a:endParaRPr lang="en-US" sz="1600" dirty="0"/>
           </a:p>
@@ -4680,7 +4695,7 @@
                 <a:ea typeface="Consolas" pitchFamily="34" charset="-122"/>
                 <a:cs typeface="Consolas" pitchFamily="34" charset="-120"/>
               </a:rPr>
-              <a:t>Reeves &amp; Nass 1996 · Schroeder &amp; Epley, Psych. Science 2015</a:t>
+              <a:t>Fernández, Hancock &amp; Jakesch, CHI 2026</a:t>
             </a:r>
             <a:endParaRPr lang="en-US" sz="1050" dirty="0"/>
           </a:p>
@@ -4772,7 +4787,7 @@
                   <a:schemeClr val="tx1"/>
                 </a:solidFill>
               </a:rPr>
-              <a:t>this work is almost all text. Few studies deliver the </a:t>
+              <a:t>no study we found gives the </a:t>
             </a:r>
             <a:pPr indent="0" marL="0">
               <a:buNone/>
@@ -4794,7 +4809,7 @@
                   <a:schemeClr val="tx1"/>
                 </a:solidFill>
               </a:rPr>
-              <a:t> explanation as text, voice and face, and measure whether people take over its mistakes.</a:t>
+              <a:t> AI explanation, with one planted mistake, as text, voice and face, and measures whether people follow it.</a:t>
             </a:r>
             <a:endParaRPr lang="en-US" sz="1600" dirty="0"/>
           </a:p>
@@ -5374,7 +5389,26 @@
               </a:rPr>
               <a:t>Checking costs more effort there, so social cues matter more.</a:t>
             </a:r>
-            <a:endParaRPr lang="en-US" sz="1500" dirty="0"/>
+          </a:p>
+          <a:p>
+            <a:pPr indent="0" marL="0">
+              <a:spcBef>
+                <a:spcPts val="600"/>
+              </a:spcBef>
+              <a:buNone/>
+            </a:pPr>
+            <a:r>
+              <a:rPr lang="en-US" sz="1050" dirty="0">
+                <a:solidFill>
+                  <a:schemeClr val="tx2"/>
+                </a:solidFill>
+                <a:latin typeface="Consolas" pitchFamily="34" charset="0"/>
+                <a:ea typeface="Consolas" pitchFamily="34" charset="-122"/>
+                <a:cs typeface="Consolas" pitchFamily="34" charset="-120"/>
+              </a:rPr>
+              <a:t>Elaboration likelihood model, Petty &amp; Cacioppo 1986</a:t>
+            </a:r>
+            <a:endParaRPr lang="en-US" sz="1050" dirty="0"/>
           </a:p>
         </p:txBody>
       </p:sp>

</xml_diff>